<commit_message>
Add California SB 707 textile EPR to business plan and deck
New section 6b covers the Responsible Textile Recovery Act of 2024:
covered products, the >$1M producer threshold, the Jul 1 2026 PRO
registration deadline, eco-modulated fees, and SKU-level data reporting —
plus five ways Duyen's product modulars serve it. Compliance slide now
shows both the EU and California fronts.

Co-Authored-By: Claude Fable 5 <noreply@anthropic.com>
Claude-Session: https://claude.ai/code/session_01WTQ3T8iebWSa3EefVWJdQP
</commit_message>
<xml_diff>
--- a/docs/duyen-pitch-deck.pptx
+++ b/docs/duyen-pitch-deck.pptx
@@ -2189,7 +2189,7 @@
           <a:p>
             <a:r>
               <a:rPr lang="en-US" dirty="0"/>
-              <a:t>DPP market: $275M (2025) → $3.0B (2033), ~35% CAGR. On-pack QR + DPP: $3.3B (2026) → $13.9B (2036). Compliance QRs are per-unit, permanent, and mandatory — non-discretionary recurring revenue on the existing $0.10/QR minting engine.</a:t>
+              <a:t>DPP market: $275M (2025) → $3.0B (2033), ~35% CAGR. SB 707: scannable care/repair/resale layer is a documentable producer reuse-and-repair program — exactly what eco-modulated fees must credit; scan logs make it auditable. Full stewardship program by 2030; fee methodology being designed now.</a:t>
             </a:r>
             <a:endParaRPr lang="en-US" dirty="0"/>
           </a:p>
@@ -9188,7 +9188,7 @@
                 <a:ea typeface="Cambria" pitchFamily="34" charset="-122"/>
                 <a:cs typeface="Cambria" pitchFamily="34" charset="-120"/>
               </a:rPr>
-              <a:t>The regulatory tailwind: textile passports</a:t>
+              <a:t>The regulatory tailwind, on two fronts</a:t>
             </a:r>
             <a:endParaRPr lang="en-US" sz="3400" dirty="0"/>
           </a:p>
@@ -9227,7 +9227,7 @@
                 <a:ea typeface="Calibri" pitchFamily="34" charset="-122"/>
                 <a:cs typeface="Calibri" pitchFamily="34" charset="-120"/>
               </a:rPr>
-              <a:t>EU ESPR: every garment sold in the EU will carry a QR-accessible Digital Product Passport.</a:t>
+              <a:t>EU ESPR: every garment carries a QR product passport. California SB 707: producers now pay for textile end-of-life.</a:t>
             </a:r>
             <a:endParaRPr lang="en-US" sz="1500" dirty="0"/>
           </a:p>
@@ -10035,11 +10035,11 @@
         <p:spPr>
           <a:xfrm>
             <a:off x="502920" y="4343400"/>
-            <a:ext cx="5532120" cy="1828800"/>
+            <a:ext cx="3611880" cy="1920240"/>
           </a:xfrm>
           <a:prstGeom prst="roundRect">
             <a:avLst>
-              <a:gd name="adj" fmla="val 5000"/>
+              <a:gd name="adj" fmla="val 4762"/>
             </a:avLst>
           </a:prstGeom>
           <a:solidFill>
@@ -10056,24 +10056,24 @@
         </p:nvSpPr>
         <p:spPr>
           <a:xfrm>
-            <a:off x="822960" y="4526280"/>
-            <a:ext cx="4937760" cy="320040"/>
-          </a:xfrm>
-          <a:prstGeom prst="rect">
-            <a:avLst/>
-          </a:prstGeom>
-          <a:noFill/>
-          <a:ln/>
-        </p:spPr>
-        <p:txBody>
-          <a:bodyPr wrap="square" lIns="0" tIns="0" rIns="0" bIns="0" rtlCol="0" anchor="ctr"/>
-          <a:lstStyle/>
-          <a:p>
-            <a:pPr indent="0" marL="0">
-              <a:buNone/>
-            </a:pPr>
-            <a:r>
-              <a:rPr lang="en-US" sz="1350" b="1" dirty="0">
+            <a:off x="777240" y="4507992"/>
+            <a:ext cx="3063240" cy="320040"/>
+          </a:xfrm>
+          <a:prstGeom prst="rect">
+            <a:avLst/>
+          </a:prstGeom>
+          <a:noFill/>
+          <a:ln/>
+        </p:spPr>
+        <p:txBody>
+          <a:bodyPr wrap="square" lIns="0" tIns="0" rIns="0" bIns="0" rtlCol="0" anchor="ctr"/>
+          <a:lstStyle/>
+          <a:p>
+            <a:pPr indent="0" marL="0">
+              <a:buNone/>
+            </a:pPr>
+            <a:r>
+              <a:rPr lang="en-US" sz="1250" b="1" dirty="0">
                 <a:solidFill>
                   <a:srgbClr val="8B3A7F"/>
                 </a:solidFill>
@@ -10081,9 +10081,9 @@
                 <a:ea typeface="Calibri" pitchFamily="34" charset="-122"/>
                 <a:cs typeface="Calibri" pitchFamily="34" charset="-120"/>
               </a:rPr>
-              <a:t>Required per garment (expected)</a:t>
-            </a:r>
-            <a:endParaRPr lang="en-US" sz="1350" dirty="0"/>
+              <a:t>EU — per-garment data</a:t>
+            </a:r>
+            <a:endParaRPr lang="en-US" sz="1250" dirty="0"/>
           </a:p>
         </p:txBody>
       </p:sp>
@@ -10095,24 +10095,24 @@
         </p:nvSpPr>
         <p:spPr>
           <a:xfrm>
-            <a:off x="822960" y="4864608"/>
-            <a:ext cx="4937760" cy="1143000"/>
-          </a:xfrm>
-          <a:prstGeom prst="rect">
-            <a:avLst/>
-          </a:prstGeom>
-          <a:noFill/>
-          <a:ln/>
-        </p:spPr>
-        <p:txBody>
-          <a:bodyPr wrap="square" lIns="0" tIns="0" rIns="0" bIns="0" rtlCol="0" anchor="ctr"/>
-          <a:lstStyle/>
-          <a:p>
-            <a:pPr indent="0" marL="0">
-              <a:buNone/>
-            </a:pPr>
-            <a:r>
-              <a:rPr lang="en-US" sz="1200" dirty="0">
+            <a:off x="777240" y="4828032"/>
+            <a:ext cx="3063240" cy="1325880"/>
+          </a:xfrm>
+          <a:prstGeom prst="rect">
+            <a:avLst/>
+          </a:prstGeom>
+          <a:noFill/>
+          <a:ln/>
+        </p:spPr>
+        <p:txBody>
+          <a:bodyPr wrap="square" lIns="0" tIns="0" rIns="0" bIns="0" rtlCol="0" anchor="t"/>
+          <a:lstStyle/>
+          <a:p>
+            <a:pPr indent="0" marL="0">
+              <a:buNone/>
+            </a:pPr>
+            <a:r>
+              <a:rPr lang="en-US" sz="1050" dirty="0">
                 <a:solidFill>
                   <a:srgbClr val="3D2E24"/>
                 </a:solidFill>
@@ -10120,9 +10120,9 @@
                 <a:ea typeface="Calibri" pitchFamily="34" charset="-122"/>
                 <a:cs typeface="Calibri" pitchFamily="34" charset="-120"/>
               </a:rPr>
-              <a:t>Fiber composition · country of manufacture · care instructions · chemical use · durability · repair &amp; resale options · environmental impact — all behind a QR on the label or hangtag.</a:t>
-            </a:r>
-            <a:endParaRPr lang="en-US" sz="1200" dirty="0"/>
+              <a:t>Fiber composition · origin · care · chemical use · durability · repair &amp; resale options · environmental impact — all behind a QR on the label or hangtag.</a:t>
+            </a:r>
+            <a:endParaRPr lang="en-US" sz="1050" dirty="0"/>
           </a:p>
         </p:txBody>
       </p:sp>
@@ -10134,12 +10134,112 @@
         </p:nvSpPr>
         <p:spPr>
           <a:xfrm>
-            <a:off x="6355080" y="4343400"/>
-            <a:ext cx="5330952" cy="1828800"/>
+            <a:off x="4288536" y="4343400"/>
+            <a:ext cx="3611880" cy="1920240"/>
           </a:xfrm>
           <a:prstGeom prst="roundRect">
             <a:avLst>
-              <a:gd name="adj" fmla="val 5000"/>
+              <a:gd name="adj" fmla="val 4762"/>
+            </a:avLst>
+          </a:prstGeom>
+          <a:solidFill>
+            <a:srgbClr val="F7F3F8"/>
+          </a:solidFill>
+          <a:ln/>
+        </p:spPr>
+      </p:sp>
+      <p:sp>
+        <p:nvSpPr>
+          <p:cNvPr id="31" name="Text 29"/>
+          <p:cNvSpPr/>
+          <p:nvPr/>
+        </p:nvSpPr>
+        <p:spPr>
+          <a:xfrm>
+            <a:off x="4562856" y="4507992"/>
+            <a:ext cx="3063240" cy="320040"/>
+          </a:xfrm>
+          <a:prstGeom prst="rect">
+            <a:avLst/>
+          </a:prstGeom>
+          <a:noFill/>
+          <a:ln/>
+        </p:spPr>
+        <p:txBody>
+          <a:bodyPr wrap="square" lIns="0" tIns="0" rIns="0" bIns="0" rtlCol="0" anchor="ctr"/>
+          <a:lstStyle/>
+          <a:p>
+            <a:pPr indent="0" marL="0">
+              <a:buNone/>
+            </a:pPr>
+            <a:r>
+              <a:rPr lang="en-US" sz="1250" b="1" dirty="0">
+                <a:solidFill>
+                  <a:srgbClr val="8B3A7F"/>
+                </a:solidFill>
+                <a:latin typeface="Calibri" pitchFamily="34" charset="0"/>
+                <a:ea typeface="Calibri" pitchFamily="34" charset="-122"/>
+                <a:cs typeface="Calibri" pitchFamily="34" charset="-120"/>
+              </a:rPr>
+              <a:t>California — SB 707 (2024)</a:t>
+            </a:r>
+            <a:endParaRPr lang="en-US" sz="1250" dirty="0"/>
+          </a:p>
+        </p:txBody>
+      </p:sp>
+      <p:sp>
+        <p:nvSpPr>
+          <p:cNvPr id="32" name="Text 30"/>
+          <p:cNvSpPr/>
+          <p:nvPr/>
+        </p:nvSpPr>
+        <p:spPr>
+          <a:xfrm>
+            <a:off x="4562856" y="4828032"/>
+            <a:ext cx="3063240" cy="1325880"/>
+          </a:xfrm>
+          <a:prstGeom prst="rect">
+            <a:avLst/>
+          </a:prstGeom>
+          <a:noFill/>
+          <a:ln/>
+        </p:spPr>
+        <p:txBody>
+          <a:bodyPr wrap="square" lIns="0" tIns="0" rIns="0" bIns="0" rtlCol="0" anchor="t"/>
+          <a:lstStyle/>
+          <a:p>
+            <a:pPr indent="0" marL="0">
+              <a:buNone/>
+            </a:pPr>
+            <a:r>
+              <a:rPr lang="en-US" sz="1050" dirty="0">
+                <a:solidFill>
+                  <a:srgbClr val="3D2E24"/>
+                </a:solidFill>
+                <a:latin typeface="Calibri" pitchFamily="34" charset="0"/>
+                <a:ea typeface="Calibri" pitchFamily="34" charset="-122"/>
+                <a:cs typeface="Calibri" pitchFamily="34" charset="-120"/>
+              </a:rPr>
+              <a:t>First US textile EPR law. Producers &gt;$1M selling into CA had to join the PRO by Jul 1, 2026 (fines to $10K/day). Eco-modulated fees reward repair &amp; reuse programs — with SKU-level data reporting.</a:t>
+            </a:r>
+            <a:endParaRPr lang="en-US" sz="1050" dirty="0"/>
+          </a:p>
+        </p:txBody>
+      </p:sp>
+      <p:sp>
+        <p:nvSpPr>
+          <p:cNvPr id="33" name="Shape 31"/>
+          <p:cNvSpPr/>
+          <p:nvPr/>
+        </p:nvSpPr>
+        <p:spPr>
+          <a:xfrm>
+            <a:off x="8074152" y="4343400"/>
+            <a:ext cx="3611880" cy="1920240"/>
+          </a:xfrm>
+          <a:prstGeom prst="roundRect">
+            <a:avLst>
+              <a:gd name="adj" fmla="val 4762"/>
             </a:avLst>
           </a:prstGeom>
           <a:solidFill>
@@ -10150,30 +10250,30 @@
       </p:sp>
       <p:sp>
         <p:nvSpPr>
-          <p:cNvPr id="31" name="Text 29"/>
-          <p:cNvSpPr/>
-          <p:nvPr/>
-        </p:nvSpPr>
-        <p:spPr>
-          <a:xfrm>
-            <a:off x="6675120" y="4526280"/>
-            <a:ext cx="4709160" cy="320040"/>
-          </a:xfrm>
-          <a:prstGeom prst="rect">
-            <a:avLst/>
-          </a:prstGeom>
-          <a:noFill/>
-          <a:ln/>
-        </p:spPr>
-        <p:txBody>
-          <a:bodyPr wrap="square" lIns="0" tIns="0" rIns="0" bIns="0" rtlCol="0" anchor="ctr"/>
-          <a:lstStyle/>
-          <a:p>
-            <a:pPr indent="0" marL="0">
-              <a:buNone/>
-            </a:pPr>
-            <a:r>
-              <a:rPr lang="en-US" sz="1350" b="1" dirty="0">
+          <p:cNvPr id="34" name="Text 32"/>
+          <p:cNvSpPr/>
+          <p:nvPr/>
+        </p:nvSpPr>
+        <p:spPr>
+          <a:xfrm>
+            <a:off x="8348472" y="4507992"/>
+            <a:ext cx="3063240" cy="320040"/>
+          </a:xfrm>
+          <a:prstGeom prst="rect">
+            <a:avLst/>
+          </a:prstGeom>
+          <a:noFill/>
+          <a:ln/>
+        </p:spPr>
+        <p:txBody>
+          <a:bodyPr wrap="square" lIns="0" tIns="0" rIns="0" bIns="0" rtlCol="0" anchor="ctr"/>
+          <a:lstStyle/>
+          <a:p>
+            <a:pPr indent="0" marL="0">
+              <a:buNone/>
+            </a:pPr>
+            <a:r>
+              <a:rPr lang="en-US" sz="1250" b="1" dirty="0">
                 <a:solidFill>
                   <a:srgbClr val="F3C6EA"/>
                 </a:solidFill>
@@ -10183,36 +10283,36 @@
               </a:rPr>
               <a:t>Why Duyên wins the long tail</a:t>
             </a:r>
-            <a:endParaRPr lang="en-US" sz="1350" dirty="0"/>
-          </a:p>
-        </p:txBody>
-      </p:sp>
-      <p:sp>
-        <p:nvSpPr>
-          <p:cNvPr id="32" name="Text 30"/>
-          <p:cNvSpPr/>
-          <p:nvPr/>
-        </p:nvSpPr>
-        <p:spPr>
-          <a:xfrm>
-            <a:off x="6675120" y="4864608"/>
-            <a:ext cx="4709160" cy="1234440"/>
-          </a:xfrm>
-          <a:prstGeom prst="rect">
-            <a:avLst/>
-          </a:prstGeom>
-          <a:noFill/>
-          <a:ln/>
-        </p:spPr>
-        <p:txBody>
-          <a:bodyPr wrap="square" lIns="0" tIns="0" rIns="0" bIns="0" rtlCol="0" anchor="ctr"/>
-          <a:lstStyle/>
-          <a:p>
-            <a:pPr indent="0" marL="0">
-              <a:buNone/>
-            </a:pPr>
-            <a:r>
-              <a:rPr lang="en-US" sz="1150" dirty="0">
+            <a:endParaRPr lang="en-US" sz="1250" dirty="0"/>
+          </a:p>
+        </p:txBody>
+      </p:sp>
+      <p:sp>
+        <p:nvSpPr>
+          <p:cNvPr id="35" name="Text 33"/>
+          <p:cNvSpPr/>
+          <p:nvPr/>
+        </p:nvSpPr>
+        <p:spPr>
+          <a:xfrm>
+            <a:off x="8348472" y="4828032"/>
+            <a:ext cx="3063240" cy="1325880"/>
+          </a:xfrm>
+          <a:prstGeom prst="rect">
+            <a:avLst/>
+          </a:prstGeom>
+          <a:noFill/>
+          <a:ln/>
+        </p:spPr>
+        <p:txBody>
+          <a:bodyPr wrap="square" lIns="0" tIns="0" rIns="0" bIns="0" rtlCol="0" anchor="t"/>
+          <a:lstStyle/>
+          <a:p>
+            <a:pPr indent="0" marL="0">
+              <a:buNone/>
+            </a:pPr>
+            <a:r>
+              <a:rPr lang="en-US" sz="1050" dirty="0">
                 <a:solidFill>
                   <a:srgbClr val="E9D8E5"/>
                 </a:solidFill>
@@ -10220,15 +10320,15 @@
                 <a:ea typeface="Calibri" pitchFamily="34" charset="-122"/>
                 <a:cs typeface="Calibri" pitchFamily="34" charset="-120"/>
               </a:rPr>
-              <a:t>Duyên's product modular is already the right shape: a per-product QR resolving to structured data + the maker's story. Enterprise platforms will fight over Inditex; millions of SMEs need a sub-$50/month answer — Duyên's existing customer and price point.</a:t>
-            </a:r>
-            <a:endParaRPr lang="en-US" sz="1150" dirty="0"/>
-          </a:p>
-        </p:txBody>
-      </p:sp>
-      <p:sp>
-        <p:nvSpPr>
-          <p:cNvPr id="33" name="Text 31"/>
+              <a:t>The product modular is already the right shape: per-product QR → structured data + the maker's story. One dataset serves EU DPP and SB 707 reporting, at a sub-$50/month price point enterprise platforms won't touch.</a:t>
+            </a:r>
+            <a:endParaRPr lang="en-US" sz="1050" dirty="0"/>
+          </a:p>
+        </p:txBody>
+      </p:sp>
+      <p:sp>
+        <p:nvSpPr>
+          <p:cNvPr id="36" name="Text 34"/>
           <p:cNvSpPr/>
           <p:nvPr/>
         </p:nvSpPr>
@@ -10267,7 +10367,7 @@
       </p:sp>
       <p:sp>
         <p:nvSpPr>
-          <p:cNvPr id="34" name="Text 32"/>
+          <p:cNvPr id="37" name="Text 35"/>
           <p:cNvSpPr/>
           <p:nvPr/>
         </p:nvSpPr>

</xml_diff>